<commit_message>
Remove a referencia a branch dos slides da Secao 2
O nome da branch e detalhe de implementacao e nao acrescenta nada na
apresentacao; os slides agora trazem apenas o link do repositorio.

Co-Authored-By: Claude Opus 5 <noreply@anthropic.com>
Claude-Session: https://claude.ai/code/session_015KbfK2yTcxqbYNLq2jRVqV
</commit_message>
<xml_diff>
--- a/docs/Fase_2_DevOps_na_Pratica_PetHub.pptx
+++ b/docs/Fase_2_DevOps_na_Pratica_PetHub.pptx
@@ -8359,24 +8359,6 @@
           <a:p>
             <a:pPr>
               <a:spcBef>
-                <a:spcPts val="0"/>
-              </a:spcBef>
-              <a:spcAft>
-                <a:spcPts val="600"/>
-              </a:spcAft>
-            </a:pPr>
-            <a:r>
-              <a:rPr sz="1500" b="0">
-                <a:solidFill>
-                  <a:srgbClr val="44445C"/>
-                </a:solidFill>
-              </a:rPr>
-              <a:t>A entrega da Fase 2 está na branch claude/projeto-fase-2-i2cfuu.</a:t>
-            </a:r>
-          </a:p>
-          <a:p>
-            <a:pPr>
-              <a:spcBef>
                 <a:spcPts val="1000"/>
               </a:spcBef>
               <a:spcAft>
@@ -8716,7 +8698,7 @@
                   <a:srgbClr val="44445C"/>
                 </a:solidFill>
               </a:rPr>
-              <a:t>https://github.com/SophiAoAmaral/Devops-fase1   (branch claude/projeto-fase-2-i2cfuu)</a:t>
+              <a:t>https://github.com/SophiAoAmaral/Devops-fase1</a:t>
             </a:r>
           </a:p>
           <a:p>

</xml_diff>

<commit_message>
Simplifica o fluxograma e aponta os slides para o repositorio atual
Co-Authored-By: Claude Opus 5 <noreply@anthropic.com>
Claude-Session: https://claude.ai/code/session_015KbfK2yTcxqbYNLq2jRVqV
</commit_message>
<xml_diff>
--- a/docs/Fase_2_DevOps_na_Pratica_PetHub.pptx
+++ b/docs/Fase_2_DevOps_na_Pratica_PetHub.pptx
@@ -7471,8 +7471,8 @@
         </p:blipFill>
         <p:spPr>
           <a:xfrm>
-            <a:off x="2287844" y="2295282"/>
-            <a:ext cx="11856842" cy="6589955"/>
+            <a:off x="1339196" y="2295282"/>
+            <a:ext cx="13754138" cy="6589955"/>
           </a:xfrm>
           <a:prstGeom prst="rect">
             <a:avLst/>
@@ -8353,7 +8353,7 @@
                   <a:srgbClr val="44445C"/>
                 </a:solidFill>
               </a:rPr>
-              <a:t>https://github.com/SophiAoAmaral/Devops-fase1</a:t>
+              <a:t>https://github.com/SophiAoAmaral/Devops-2</a:t>
             </a:r>
           </a:p>
           <a:p>
@@ -8698,7 +8698,7 @@
                   <a:srgbClr val="44445C"/>
                 </a:solidFill>
               </a:rPr>
-              <a:t>https://github.com/SophiAoAmaral/Devops-fase1</a:t>
+              <a:t>https://github.com/SophiAoAmaral/Devops-2</a:t>
             </a:r>
           </a:p>
           <a:p>

</xml_diff>